<commit_message>
update (apresentação): Revisão da apresentação do projeto.
</commit_message>
<xml_diff>
--- a/docs/apresentacao_projeto_churn.pptx
+++ b/docs/apresentacao_projeto_churn.pptx
@@ -3614,7 +3614,7 @@
                 </a:solidFill>
                 <a:latin typeface="Aptos"/>
               </a:rPr>
-              <a:t>Apresentação das etapas realizadas até o momento</a:t>
+              <a:t>Apresentação da análise revisada</a:t>
             </a:r>
           </a:p>
         </p:txBody>
@@ -3684,7 +3684,7 @@
                 </a:solidFill>
                 <a:latin typeface="Aptos"/>
               </a:rPr>
-              <a:t>21/08/2026</a:t>
+              <a:t>23/08/2026</a:t>
             </a:r>
           </a:p>
         </p:txBody>
@@ -4187,7 +4187,7 @@
                 </a:solidFill>
                 <a:latin typeface="Aptos"/>
               </a:rPr>
-              <a:t>É o modelo e o threshold que melhor equilibram retenção, custo de abordagem e revisão humana.</a:t>
+              <a:t>É o modelo e o threshold que melhor equilibram retenção, custo de abordagem e revisão humana, após a reexecução do notebook.</a:t>
             </a:r>
           </a:p>
         </p:txBody>
@@ -5246,7 +5246,7 @@
                 </a:solidFill>
                 <a:latin typeface="Aptos"/>
               </a:rPr>
-              <a:t>A fundação técnica está estruturada. As principais pendências estão na consolidação experimental do baseline, na execução do ambiente e na finalização da entrega audiovisual.</a:t>
+              <a:t>A fundação técnica está estruturada. A análise foi corrigida para ser reproduzível, mas as células e os resultados finais ainda precisam ser reexecutados no ambiente com o dataset.</a:t>
             </a:r>
           </a:p>
         </p:txBody>
@@ -5839,7 +5839,7 @@
                 </a:solidFill>
                 <a:latin typeface="Aptos"/>
               </a:rPr>
-              <a:t>O ML Canvas existe, mas precisa ser alinhado aos números e ao protocolo final do projeto.</a:t>
+              <a:t>A métrica técnica e o objetivo operacional precisam ser avaliados juntos.</a:t>
             </a:r>
           </a:p>
         </p:txBody>
@@ -6646,7 +6646,7 @@
               </a:defRPr>
             </a:pPr>
             <a:r>
-              <a:t>• TotalCharges precisa ser convertido para numérico</a:t>
+              <a:t>• TotalCharges é convertido e linhas inválidas são removidas</a:t>
             </a:r>
           </a:p>
           <a:p>
@@ -6662,7 +6662,7 @@
               </a:defRPr>
             </a:pPr>
             <a:r>
-              <a:t>• customerID é removido do treinamento</a:t>
+              <a:t>• customerID é removido de forma repetível</a:t>
             </a:r>
           </a:p>
           <a:p>
@@ -6694,7 +6694,7 @@
               </a:defRPr>
             </a:pPr>
             <a:r>
-              <a:t>• Notebook tem caminho absoluto e célula com erro</a:t>
+              <a:t>• Saídas persistidas ainda precisam de reexecução</a:t>
             </a:r>
           </a:p>
         </p:txBody>
@@ -7588,7 +7588,7 @@
                 </a:solidFill>
                 <a:latin typeface="Aptos"/>
               </a:rPr>
-              <a:t>RF / MLP</a:t>
+              <a:t>Logística / RF / MLP</a:t>
             </a:r>
           </a:p>
         </p:txBody>
@@ -8162,7 +8162,7 @@
         <p:spPr>
           <a:xfrm>
             <a:off x="5394960" y="1828800"/>
-            <a:ext cx="1920240" cy="502920"/>
+            <a:ext cx="5760720" cy="502920"/>
           </a:xfrm>
           <a:prstGeom prst="rect">
             <a:avLst/>
@@ -8207,7 +8207,7 @@
         <p:spPr>
           <a:xfrm>
             <a:off x="5468112" y="1975104"/>
-            <a:ext cx="1773936" cy="182880"/>
+            <a:ext cx="5614416" cy="182880"/>
           </a:xfrm>
           <a:prstGeom prst="rect">
             <a:avLst/>
@@ -8228,7 +8228,7 @@
                 </a:solidFill>
                 <a:latin typeface="Aptos"/>
               </a:rPr>
-              <a:t>Accuracy</a:t>
+              <a:t>Status</a:t>
             </a:r>
           </a:p>
         </p:txBody>
@@ -8236,166 +8236,6 @@
       <p:sp>
         <p:nvSpPr>
           <p:cNvPr id="12" name="Rectangle 11"/>
-          <p:cNvSpPr/>
-          <p:nvPr/>
-        </p:nvSpPr>
-        <p:spPr>
-          <a:xfrm>
-            <a:off x="7315200" y="1828800"/>
-            <a:ext cx="1920240" cy="502920"/>
-          </a:xfrm>
-          <a:prstGeom prst="rect">
-            <a:avLst/>
-          </a:prstGeom>
-          <a:solidFill>
-            <a:srgbClr val="0E1D2F"/>
-          </a:solidFill>
-          <a:ln>
-            <a:solidFill>
-              <a:srgbClr val="0E1D2F"/>
-            </a:solidFill>
-          </a:ln>
-        </p:spPr>
-        <p:style>
-          <a:lnRef idx="1">
-            <a:schemeClr val="accent1"/>
-          </a:lnRef>
-          <a:fillRef idx="3">
-            <a:schemeClr val="accent1"/>
-          </a:fillRef>
-          <a:effectRef idx="2">
-            <a:schemeClr val="accent1"/>
-          </a:effectRef>
-          <a:fontRef idx="minor">
-            <a:schemeClr val="lt1"/>
-          </a:fontRef>
-        </p:style>
-        <p:txBody>
-          <a:bodyPr rtlCol="0" anchor="ctr"/>
-          <a:lstStyle/>
-          <a:p>
-            <a:pPr algn="ctr"/>
-          </a:p>
-        </p:txBody>
-      </p:sp>
-      <p:sp>
-        <p:nvSpPr>
-          <p:cNvPr id="13" name="TextBox 12"/>
-          <p:cNvSpPr txBox="1"/>
-          <p:nvPr/>
-        </p:nvSpPr>
-        <p:spPr>
-          <a:xfrm>
-            <a:off x="7388352" y="1975104"/>
-            <a:ext cx="1773936" cy="182880"/>
-          </a:xfrm>
-          <a:prstGeom prst="rect">
-            <a:avLst/>
-          </a:prstGeom>
-          <a:noFill/>
-        </p:spPr>
-        <p:txBody>
-          <a:bodyPr wrap="square" lIns="36576" rIns="36576" tIns="18288" anchor="t">
-            <a:spAutoFit/>
-          </a:bodyPr>
-          <a:lstStyle/>
-          <a:p>
-            <a:pPr algn="ctr"/>
-            <a:r>
-              <a:rPr sz="1100" b="1">
-                <a:solidFill>
-                  <a:srgbClr val="FFFFFF"/>
-                </a:solidFill>
-                <a:latin typeface="Aptos"/>
-              </a:rPr>
-              <a:t>Recall</a:t>
-            </a:r>
-          </a:p>
-        </p:txBody>
-      </p:sp>
-      <p:sp>
-        <p:nvSpPr>
-          <p:cNvPr id="14" name="Rectangle 13"/>
-          <p:cNvSpPr/>
-          <p:nvPr/>
-        </p:nvSpPr>
-        <p:spPr>
-          <a:xfrm>
-            <a:off x="9235440" y="1828800"/>
-            <a:ext cx="1920240" cy="502920"/>
-          </a:xfrm>
-          <a:prstGeom prst="rect">
-            <a:avLst/>
-          </a:prstGeom>
-          <a:solidFill>
-            <a:srgbClr val="0E1D2F"/>
-          </a:solidFill>
-          <a:ln>
-            <a:solidFill>
-              <a:srgbClr val="0E1D2F"/>
-            </a:solidFill>
-          </a:ln>
-        </p:spPr>
-        <p:style>
-          <a:lnRef idx="1">
-            <a:schemeClr val="accent1"/>
-          </a:lnRef>
-          <a:fillRef idx="3">
-            <a:schemeClr val="accent1"/>
-          </a:fillRef>
-          <a:effectRef idx="2">
-            <a:schemeClr val="accent1"/>
-          </a:effectRef>
-          <a:fontRef idx="minor">
-            <a:schemeClr val="lt1"/>
-          </a:fontRef>
-        </p:style>
-        <p:txBody>
-          <a:bodyPr rtlCol="0" anchor="ctr"/>
-          <a:lstStyle/>
-          <a:p>
-            <a:pPr algn="ctr"/>
-          </a:p>
-        </p:txBody>
-      </p:sp>
-      <p:sp>
-        <p:nvSpPr>
-          <p:cNvPr id="15" name="TextBox 14"/>
-          <p:cNvSpPr txBox="1"/>
-          <p:nvPr/>
-        </p:nvSpPr>
-        <p:spPr>
-          <a:xfrm>
-            <a:off x="9308592" y="1975104"/>
-            <a:ext cx="1773936" cy="182880"/>
-          </a:xfrm>
-          <a:prstGeom prst="rect">
-            <a:avLst/>
-          </a:prstGeom>
-          <a:noFill/>
-        </p:spPr>
-        <p:txBody>
-          <a:bodyPr wrap="square" lIns="36576" rIns="36576" tIns="18288" anchor="t">
-            <a:spAutoFit/>
-          </a:bodyPr>
-          <a:lstStyle/>
-          <a:p>
-            <a:pPr algn="ctr"/>
-            <a:r>
-              <a:rPr sz="1100" b="1">
-                <a:solidFill>
-                  <a:srgbClr val="FFFFFF"/>
-                </a:solidFill>
-                <a:latin typeface="Aptos"/>
-              </a:rPr>
-              <a:t>F1</a:t>
-            </a:r>
-          </a:p>
-        </p:txBody>
-      </p:sp>
-      <p:sp>
-        <p:nvSpPr>
-          <p:cNvPr id="16" name="Rectangle 15"/>
           <p:cNvSpPr/>
           <p:nvPr/>
         </p:nvSpPr>
@@ -8440,7 +8280,7 @@
       </p:sp>
       <p:sp>
         <p:nvSpPr>
-          <p:cNvPr id="17" name="TextBox 16"/>
+          <p:cNvPr id="13" name="TextBox 12"/>
           <p:cNvSpPr txBox="1"/>
           <p:nvPr/>
         </p:nvSpPr>
@@ -8475,7 +8315,7 @@
       </p:sp>
       <p:sp>
         <p:nvSpPr>
-          <p:cNvPr id="18" name="Rectangle 17"/>
+          <p:cNvPr id="14" name="Rectangle 13"/>
           <p:cNvSpPr/>
           <p:nvPr/>
         </p:nvSpPr>
@@ -8520,7 +8360,7 @@
       </p:sp>
       <p:sp>
         <p:nvSpPr>
-          <p:cNvPr id="19" name="TextBox 18"/>
+          <p:cNvPr id="15" name="TextBox 14"/>
           <p:cNvSpPr txBox="1"/>
           <p:nvPr/>
         </p:nvSpPr>
@@ -8555,14 +8395,14 @@
       </p:sp>
       <p:sp>
         <p:nvSpPr>
-          <p:cNvPr id="20" name="Rectangle 19"/>
+          <p:cNvPr id="16" name="Rectangle 15"/>
           <p:cNvSpPr/>
           <p:nvPr/>
         </p:nvSpPr>
         <p:spPr>
           <a:xfrm>
             <a:off x="5394960" y="2359152"/>
-            <a:ext cx="1920240" cy="530352"/>
+            <a:ext cx="5760720" cy="530352"/>
           </a:xfrm>
           <a:prstGeom prst="rect">
             <a:avLst/>
@@ -8600,14 +8440,14 @@
       </p:sp>
       <p:sp>
         <p:nvSpPr>
-          <p:cNvPr id="21" name="TextBox 20"/>
+          <p:cNvPr id="17" name="TextBox 16"/>
           <p:cNvSpPr txBox="1"/>
           <p:nvPr/>
         </p:nvSpPr>
         <p:spPr>
           <a:xfrm>
             <a:off x="5468112" y="2505456"/>
-            <a:ext cx="1773936" cy="182880"/>
+            <a:ext cx="5614416" cy="182880"/>
           </a:xfrm>
           <a:prstGeom prst="rect">
             <a:avLst/>
@@ -8628,21 +8468,21 @@
                 </a:solidFill>
                 <a:latin typeface="Aptos"/>
               </a:rPr>
-              <a:t>0,7948</a:t>
-            </a:r>
-          </a:p>
-        </p:txBody>
-      </p:sp>
-      <p:sp>
-        <p:nvSpPr>
-          <p:cNvPr id="22" name="Rectangle 21"/>
+              <a:t>registrada no CSV modular</a:t>
+            </a:r>
+          </a:p>
+        </p:txBody>
+      </p:sp>
+      <p:sp>
+        <p:nvSpPr>
+          <p:cNvPr id="18" name="Rectangle 17"/>
           <p:cNvSpPr/>
           <p:nvPr/>
         </p:nvSpPr>
         <p:spPr>
           <a:xfrm>
-            <a:off x="7315200" y="2359152"/>
-            <a:ext cx="1920240" cy="530352"/>
+            <a:off x="640080" y="2926080"/>
+            <a:ext cx="2743200" cy="530352"/>
           </a:xfrm>
           <a:prstGeom prst="rect">
             <a:avLst/>
@@ -8680,14 +8520,14 @@
       </p:sp>
       <p:sp>
         <p:nvSpPr>
-          <p:cNvPr id="23" name="TextBox 22"/>
-          <p:cNvSpPr txBox="1"/>
-          <p:nvPr/>
-        </p:nvSpPr>
-        <p:spPr>
-          <a:xfrm>
-            <a:off x="7388352" y="2505456"/>
-            <a:ext cx="1773936" cy="182880"/>
+          <p:cNvPr id="19" name="TextBox 18"/>
+          <p:cNvSpPr txBox="1"/>
+          <p:nvPr/>
+        </p:nvSpPr>
+        <p:spPr>
+          <a:xfrm>
+            <a:off x="713231" y="3072384"/>
+            <a:ext cx="2596896" cy="182880"/>
           </a:xfrm>
           <a:prstGeom prst="rect">
             <a:avLst/>
@@ -8702,27 +8542,27 @@
           <a:p>
             <a:pPr algn="ctr"/>
             <a:r>
-              <a:rPr sz="1400" b="0">
+              <a:rPr sz="1400" b="1">
                 <a:solidFill>
                   <a:srgbClr val="1F2D3D"/>
                 </a:solidFill>
                 <a:latin typeface="Aptos"/>
               </a:rPr>
-              <a:t>0,5223</a:t>
-            </a:r>
-          </a:p>
-        </p:txBody>
-      </p:sp>
-      <p:sp>
-        <p:nvSpPr>
-          <p:cNvPr id="24" name="Rectangle 23"/>
+              <a:t>Random Forest</a:t>
+            </a:r>
+          </a:p>
+        </p:txBody>
+      </p:sp>
+      <p:sp>
+        <p:nvSpPr>
+          <p:cNvPr id="20" name="Rectangle 19"/>
           <p:cNvSpPr/>
           <p:nvPr/>
         </p:nvSpPr>
         <p:spPr>
           <a:xfrm>
-            <a:off x="9235440" y="2359152"/>
-            <a:ext cx="1920240" cy="530352"/>
+            <a:off x="3383280" y="2926080"/>
+            <a:ext cx="2011680" cy="530352"/>
           </a:xfrm>
           <a:prstGeom prst="rect">
             <a:avLst/>
@@ -8760,14 +8600,14 @@
       </p:sp>
       <p:sp>
         <p:nvSpPr>
-          <p:cNvPr id="25" name="TextBox 24"/>
-          <p:cNvSpPr txBox="1"/>
-          <p:nvPr/>
-        </p:nvSpPr>
-        <p:spPr>
-          <a:xfrm>
-            <a:off x="9308592" y="2505456"/>
-            <a:ext cx="1773936" cy="182880"/>
+          <p:cNvPr id="21" name="TextBox 20"/>
+          <p:cNvSpPr txBox="1"/>
+          <p:nvPr/>
+        </p:nvSpPr>
+        <p:spPr>
+          <a:xfrm>
+            <a:off x="3456432" y="3072384"/>
+            <a:ext cx="1865376" cy="182880"/>
           </a:xfrm>
           <a:prstGeom prst="rect">
             <a:avLst/>
@@ -8788,21 +8628,21 @@
                 </a:solidFill>
                 <a:latin typeface="Aptos"/>
               </a:rPr>
-              <a:t>0,5751</a:t>
-            </a:r>
-          </a:p>
-        </p:txBody>
-      </p:sp>
-      <p:sp>
-        <p:nvSpPr>
-          <p:cNvPr id="26" name="Rectangle 25"/>
+              <a:t>0,8477</a:t>
+            </a:r>
+          </a:p>
+        </p:txBody>
+      </p:sp>
+      <p:sp>
+        <p:nvSpPr>
+          <p:cNvPr id="22" name="Rectangle 21"/>
           <p:cNvSpPr/>
           <p:nvPr/>
         </p:nvSpPr>
         <p:spPr>
           <a:xfrm>
-            <a:off x="640080" y="2926080"/>
-            <a:ext cx="2743200" cy="530352"/>
+            <a:off x="5394960" y="2926080"/>
+            <a:ext cx="5760720" cy="530352"/>
           </a:xfrm>
           <a:prstGeom prst="rect">
             <a:avLst/>
@@ -8840,14 +8680,14 @@
       </p:sp>
       <p:sp>
         <p:nvSpPr>
-          <p:cNvPr id="27" name="TextBox 26"/>
-          <p:cNvSpPr txBox="1"/>
-          <p:nvPr/>
-        </p:nvSpPr>
-        <p:spPr>
-          <a:xfrm>
-            <a:off x="713231" y="3072384"/>
-            <a:ext cx="2596896" cy="182880"/>
+          <p:cNvPr id="23" name="TextBox 22"/>
+          <p:cNvSpPr txBox="1"/>
+          <p:nvPr/>
+        </p:nvSpPr>
+        <p:spPr>
+          <a:xfrm>
+            <a:off x="5468112" y="3072384"/>
+            <a:ext cx="5614416" cy="182880"/>
           </a:xfrm>
           <a:prstGeom prst="rect">
             <a:avLst/>
@@ -8862,27 +8702,27 @@
           <a:p>
             <a:pPr algn="ctr"/>
             <a:r>
-              <a:rPr sz="1400" b="1">
+              <a:rPr sz="1400" b="0">
                 <a:solidFill>
                   <a:srgbClr val="1F2D3D"/>
                 </a:solidFill>
                 <a:latin typeface="Aptos"/>
               </a:rPr>
-              <a:t>Random Forest</a:t>
-            </a:r>
-          </a:p>
-        </p:txBody>
-      </p:sp>
-      <p:sp>
-        <p:nvSpPr>
-          <p:cNvPr id="28" name="Rectangle 27"/>
+              <a:t>registrada no CSV modular</a:t>
+            </a:r>
+          </a:p>
+        </p:txBody>
+      </p:sp>
+      <p:sp>
+        <p:nvSpPr>
+          <p:cNvPr id="24" name="Rectangle 23"/>
           <p:cNvSpPr/>
           <p:nvPr/>
         </p:nvSpPr>
         <p:spPr>
           <a:xfrm>
-            <a:off x="3383280" y="2926080"/>
-            <a:ext cx="2011680" cy="530352"/>
+            <a:off x="640080" y="3493008"/>
+            <a:ext cx="2743200" cy="530352"/>
           </a:xfrm>
           <a:prstGeom prst="rect">
             <a:avLst/>
@@ -8920,14 +8760,14 @@
       </p:sp>
       <p:sp>
         <p:nvSpPr>
-          <p:cNvPr id="29" name="TextBox 28"/>
-          <p:cNvSpPr txBox="1"/>
-          <p:nvPr/>
-        </p:nvSpPr>
-        <p:spPr>
-          <a:xfrm>
-            <a:off x="3456432" y="3072384"/>
-            <a:ext cx="1865376" cy="182880"/>
+          <p:cNvPr id="25" name="TextBox 24"/>
+          <p:cNvSpPr txBox="1"/>
+          <p:nvPr/>
+        </p:nvSpPr>
+        <p:spPr>
+          <a:xfrm>
+            <a:off x="713231" y="3639312"/>
+            <a:ext cx="2596896" cy="182880"/>
           </a:xfrm>
           <a:prstGeom prst="rect">
             <a:avLst/>
@@ -8942,27 +8782,27 @@
           <a:p>
             <a:pPr algn="ctr"/>
             <a:r>
-              <a:rPr sz="1400" b="0">
+              <a:rPr sz="1400" b="1">
                 <a:solidFill>
                   <a:srgbClr val="1F2D3D"/>
                 </a:solidFill>
                 <a:latin typeface="Aptos"/>
               </a:rPr>
-              <a:t>0,8477</a:t>
-            </a:r>
-          </a:p>
-        </p:txBody>
-      </p:sp>
-      <p:sp>
-        <p:nvSpPr>
-          <p:cNvPr id="30" name="Rectangle 29"/>
+              <a:t>Logística</a:t>
+            </a:r>
+          </a:p>
+        </p:txBody>
+      </p:sp>
+      <p:sp>
+        <p:nvSpPr>
+          <p:cNvPr id="26" name="Rectangle 25"/>
           <p:cNvSpPr/>
           <p:nvPr/>
         </p:nvSpPr>
         <p:spPr>
           <a:xfrm>
-            <a:off x="5394960" y="2926080"/>
-            <a:ext cx="1920240" cy="530352"/>
+            <a:off x="3383280" y="3493008"/>
+            <a:ext cx="2011680" cy="530352"/>
           </a:xfrm>
           <a:prstGeom prst="rect">
             <a:avLst/>
@@ -9000,14 +8840,14 @@
       </p:sp>
       <p:sp>
         <p:nvSpPr>
-          <p:cNvPr id="31" name="TextBox 30"/>
-          <p:cNvSpPr txBox="1"/>
-          <p:nvPr/>
-        </p:nvSpPr>
-        <p:spPr>
-          <a:xfrm>
-            <a:off x="5468112" y="3072384"/>
-            <a:ext cx="1773936" cy="182880"/>
+          <p:cNvPr id="27" name="TextBox 26"/>
+          <p:cNvSpPr txBox="1"/>
+          <p:nvPr/>
+        </p:nvSpPr>
+        <p:spPr>
+          <a:xfrm>
+            <a:off x="3456432" y="3639312"/>
+            <a:ext cx="1865376" cy="182880"/>
           </a:xfrm>
           <a:prstGeom prst="rect">
             <a:avLst/>
@@ -9028,27 +8868,27 @@
                 </a:solidFill>
                 <a:latin typeface="Aptos"/>
               </a:rPr>
-              <a:t>0,7502</a:t>
-            </a:r>
-          </a:p>
-        </p:txBody>
-      </p:sp>
-      <p:sp>
-        <p:nvSpPr>
-          <p:cNvPr id="32" name="Rectangle 31"/>
+              <a:t>0,8456</a:t>
+            </a:r>
+          </a:p>
+        </p:txBody>
+      </p:sp>
+      <p:sp>
+        <p:nvSpPr>
+          <p:cNvPr id="28" name="Rectangle 27"/>
           <p:cNvSpPr/>
           <p:nvPr/>
         </p:nvSpPr>
         <p:spPr>
           <a:xfrm>
-            <a:off x="7315200" y="2926080"/>
-            <a:ext cx="1920240" cy="530352"/>
+            <a:off x="5394960" y="3493008"/>
+            <a:ext cx="5760720" cy="530352"/>
           </a:xfrm>
           <a:prstGeom prst="rect">
             <a:avLst/>
           </a:prstGeom>
           <a:solidFill>
-            <a:srgbClr val="B7EBDC"/>
+            <a:srgbClr val="FFFFFF"/>
           </a:solidFill>
           <a:ln>
             <a:solidFill>
@@ -9080,14 +8920,14 @@
       </p:sp>
       <p:sp>
         <p:nvSpPr>
-          <p:cNvPr id="33" name="TextBox 32"/>
-          <p:cNvSpPr txBox="1"/>
-          <p:nvPr/>
-        </p:nvSpPr>
-        <p:spPr>
-          <a:xfrm>
-            <a:off x="7388352" y="3072384"/>
-            <a:ext cx="1773936" cy="182880"/>
+          <p:cNvPr id="29" name="TextBox 28"/>
+          <p:cNvSpPr txBox="1"/>
+          <p:nvPr/>
+        </p:nvSpPr>
+        <p:spPr>
+          <a:xfrm>
+            <a:off x="5468112" y="3639312"/>
+            <a:ext cx="5614416" cy="182880"/>
           </a:xfrm>
           <a:prstGeom prst="rect">
             <a:avLst/>
@@ -9102,106 +8942,26 @@
           <a:p>
             <a:pPr algn="ctr"/>
             <a:r>
-              <a:rPr sz="1400" b="1">
+              <a:rPr sz="1400" b="0">
                 <a:solidFill>
                   <a:srgbClr val="1F2D3D"/>
                 </a:solidFill>
                 <a:latin typeface="Aptos"/>
               </a:rPr>
-              <a:t>0,7790</a:t>
-            </a:r>
-          </a:p>
-        </p:txBody>
-      </p:sp>
-      <p:sp>
-        <p:nvSpPr>
-          <p:cNvPr id="34" name="Rectangle 33"/>
-          <p:cNvSpPr/>
-          <p:nvPr/>
-        </p:nvSpPr>
-        <p:spPr>
-          <a:xfrm>
-            <a:off x="9235440" y="2926080"/>
-            <a:ext cx="1920240" cy="530352"/>
-          </a:xfrm>
-          <a:prstGeom prst="rect">
-            <a:avLst/>
-          </a:prstGeom>
-          <a:solidFill>
-            <a:srgbClr val="B7EBDC"/>
-          </a:solidFill>
-          <a:ln>
-            <a:solidFill>
-              <a:srgbClr val="F7F5EF"/>
-            </a:solidFill>
-          </a:ln>
-        </p:spPr>
-        <p:style>
-          <a:lnRef idx="1">
-            <a:schemeClr val="accent1"/>
-          </a:lnRef>
-          <a:fillRef idx="3">
-            <a:schemeClr val="accent1"/>
-          </a:fillRef>
-          <a:effectRef idx="2">
-            <a:schemeClr val="accent1"/>
-          </a:effectRef>
-          <a:fontRef idx="minor">
-            <a:schemeClr val="lt1"/>
-          </a:fontRef>
-        </p:style>
-        <p:txBody>
-          <a:bodyPr rtlCol="0" anchor="ctr"/>
-          <a:lstStyle/>
-          <a:p>
-            <a:pPr algn="ctr"/>
-          </a:p>
-        </p:txBody>
-      </p:sp>
-      <p:sp>
-        <p:nvSpPr>
-          <p:cNvPr id="35" name="TextBox 34"/>
-          <p:cNvSpPr txBox="1"/>
-          <p:nvPr/>
-        </p:nvSpPr>
-        <p:spPr>
-          <a:xfrm>
-            <a:off x="9308592" y="3072384"/>
-            <a:ext cx="1773936" cy="182880"/>
-          </a:xfrm>
-          <a:prstGeom prst="rect">
-            <a:avLst/>
-          </a:prstGeom>
-          <a:noFill/>
-        </p:spPr>
-        <p:txBody>
-          <a:bodyPr wrap="square" lIns="36576" rIns="36576" tIns="18288" anchor="t">
-            <a:spAutoFit/>
-          </a:bodyPr>
-          <a:lstStyle/>
-          <a:p>
-            <a:pPr algn="ctr"/>
-            <a:r>
-              <a:rPr sz="1400" b="1">
-                <a:solidFill>
-                  <a:srgbClr val="1F2D3D"/>
-                </a:solidFill>
-                <a:latin typeface="Aptos"/>
-              </a:rPr>
-              <a:t>0,6238</a:t>
-            </a:r>
-          </a:p>
-        </p:txBody>
-      </p:sp>
-      <p:sp>
-        <p:nvSpPr>
-          <p:cNvPr id="36" name="TextBox 35"/>
-          <p:cNvSpPr txBox="1"/>
-          <p:nvPr/>
-        </p:nvSpPr>
-        <p:spPr>
-          <a:xfrm>
-            <a:off x="640080" y="3794760"/>
+              <a:t>saída histórica do notebook</a:t>
+            </a:r>
+          </a:p>
+        </p:txBody>
+      </p:sp>
+      <p:sp>
+        <p:nvSpPr>
+          <p:cNvPr id="30" name="TextBox 29"/>
+          <p:cNvSpPr txBox="1"/>
+          <p:nvPr/>
+        </p:nvSpPr>
+        <p:spPr>
+          <a:xfrm>
+            <a:off x="640080" y="4407408"/>
             <a:ext cx="2743200" cy="274320"/>
           </a:xfrm>
           <a:prstGeom prst="rect">
@@ -9230,14 +8990,14 @@
       </p:sp>
       <p:sp>
         <p:nvSpPr>
-          <p:cNvPr id="37" name="TextBox 36"/>
-          <p:cNvSpPr txBox="1"/>
-          <p:nvPr/>
-        </p:nvSpPr>
-        <p:spPr>
-          <a:xfrm>
-            <a:off x="640080" y="4187952"/>
-            <a:ext cx="6675120" cy="1234440"/>
+          <p:cNvPr id="31" name="TextBox 30"/>
+          <p:cNvSpPr txBox="1"/>
+          <p:nvPr/>
+        </p:nvSpPr>
+        <p:spPr>
+          <a:xfrm>
+            <a:off x="640080" y="4800600"/>
+            <a:ext cx="7315200" cy="914400"/>
           </a:xfrm>
           <a:prstGeom prst="rect">
             <a:avLst/>
@@ -9254,7 +9014,7 @@
               <a:spcAft>
                 <a:spcPts val="500"/>
               </a:spcAft>
-              <a:defRPr sz="1500">
+              <a:defRPr sz="1400">
                 <a:solidFill>
                   <a:srgbClr val="1F2D3D"/>
                 </a:solidFill>
@@ -9262,7 +9022,7 @@
               </a:defRPr>
             </a:pPr>
             <a:r>
-              <a:t>• MLP: mais accuracy e precision; menos recall</a:t>
+              <a:t>• A MLP lidera a CV por apenas 0,0004</a:t>
             </a:r>
           </a:p>
           <a:p>
@@ -9270,7 +9030,7 @@
               <a:spcAft>
                 <a:spcPts val="500"/>
               </a:spcAft>
-              <a:defRPr sz="1500">
+              <a:defRPr sz="1400">
                 <a:solidFill>
                   <a:srgbClr val="1F2D3D"/>
                 </a:solidFill>
@@ -9278,7 +9038,7 @@
               </a:defRPr>
             </a:pPr>
             <a:r>
-              <a:t>• Random Forest: identifica mais clientes que podem cancelar</a:t>
+              <a:t>• A diferença é menor que a variabilidade dos folds</a:t>
             </a:r>
           </a:p>
           <a:p>
@@ -9286,7 +9046,7 @@
               <a:spcAft>
                 <a:spcPts val="500"/>
               </a:spcAft>
-              <a:defRPr sz="1500">
+              <a:defRPr sz="1400">
                 <a:solidFill>
                   <a:srgbClr val="1F2D3D"/>
                 </a:solidFill>
@@ -9294,7 +9054,7 @@
               </a:defRPr>
             </a:pPr>
             <a:r>
-              <a:t>• A regra técnica escolhe MLP, mas a regra operacional pode preferir RF</a:t>
+              <a:t>• A comparação de teste depende da execução revisada</a:t>
             </a:r>
           </a:p>
           <a:p>
@@ -9302,7 +9062,7 @@
               <a:spcAft>
                 <a:spcPts val="500"/>
               </a:spcAft>
-              <a:defRPr sz="1500">
+              <a:defRPr sz="1400">
                 <a:solidFill>
                   <a:srgbClr val="1F2D3D"/>
                 </a:solidFill>
@@ -9317,7 +9077,7 @@
       </p:sp>
       <p:sp>
         <p:nvSpPr>
-          <p:cNvPr id="38" name="Rounded Rectangle 37"/>
+          <p:cNvPr id="32" name="Rounded Rectangle 31"/>
           <p:cNvSpPr/>
           <p:nvPr/>
         </p:nvSpPr>
@@ -9364,7 +9124,7 @@
       </p:sp>
       <p:sp>
         <p:nvSpPr>
-          <p:cNvPr id="39" name="TextBox 38"/>
+          <p:cNvPr id="33" name="TextBox 32"/>
           <p:cNvSpPr txBox="1"/>
           <p:nvPr/>
         </p:nvSpPr>
@@ -9399,7 +9159,7 @@
       </p:sp>
       <p:sp>
         <p:nvSpPr>
-          <p:cNvPr id="40" name="TextBox 39"/>
+          <p:cNvPr id="34" name="TextBox 33"/>
           <p:cNvSpPr txBox="1"/>
           <p:nvPr/>
         </p:nvSpPr>
@@ -9428,7 +9188,7 @@
                 <a:latin typeface="Aptos Display"/>
               </a:rPr>
               <a:t>MLP selecionada
-para a API</a:t>
+pela regra de CV</a:t>
             </a:r>
           </a:p>
         </p:txBody>
@@ -10255,13 +10015,14 @@
           <a:p>
             <a:pPr algn="ctr"/>
             <a:r>
-              <a:rPr sz="2400" b="1">
+              <a:rPr sz="1600" b="1">
                 <a:solidFill>
                   <a:srgbClr val="B7EBDC"/>
                 </a:solidFill>
                 <a:latin typeface="Aptos Display"/>
               </a:rPr>
-              <a:t>0,6871</a:t>
+              <a:t>valor depende
+do cliente</a:t>
             </a:r>
           </a:p>
         </p:txBody>
@@ -10960,7 +10721,7 @@
                 </a:solidFill>
                 <a:latin typeface="Aptos"/>
               </a:rPr>
-              <a:t>A documentação está mais madura que a execução local: os artefatos `.joblib`, dependências instaladas e vídeo ainda precisam ser finalizados.</a:t>
+              <a:t>A documentação está mais madura que a execução local: é necessário instalar dependências, disponibilizar o dataset, reexecutar o notebook e confirmar os artefatos `.joblib`.</a:t>
             </a:r>
           </a:p>
         </p:txBody>
@@ -11208,7 +10969,7 @@
                 </a:solidFill>
                 <a:latin typeface="Aptos"/>
               </a:rPr>
-              <a:t>Alinhar o ML Canvas</a:t>
+              <a:t>Executar o notebook</a:t>
             </a:r>
           </a:p>
         </p:txBody>
@@ -11243,7 +11004,7 @@
                 </a:solidFill>
                 <a:latin typeface="Aptos"/>
               </a:rPr>
-              <a:t>corrigir split, métricas e meta de negócio</a:t>
+              <a:t>baixar o dataset e rodar todas as células em ordem</a:t>
             </a:r>
           </a:p>
         </p:txBody>
@@ -11395,7 +11156,7 @@
                 </a:solidFill>
                 <a:latin typeface="Aptos"/>
               </a:rPr>
-              <a:t>incluir Logistic Regression no relatório modular</a:t>
+              <a:t>registrar Logística, RF e MLP no mesmo relatório</a:t>
             </a:r>
           </a:p>
         </p:txBody>
@@ -11512,7 +11273,7 @@
                 </a:solidFill>
                 <a:latin typeface="Aptos"/>
               </a:rPr>
-              <a:t>Preparar o ambiente</a:t>
+              <a:t>Validar a decisão</a:t>
             </a:r>
           </a:p>
         </p:txBody>
@@ -11547,7 +11308,7 @@
                 </a:solidFill>
                 <a:latin typeface="Aptos"/>
               </a:rPr>
-              <a:t>instalar dependências e executar pytest</a:t>
+              <a:t>comparar teste, threshold e custos de negócio</a:t>
             </a:r>
           </a:p>
         </p:txBody>
@@ -11699,7 +11460,7 @@
                 </a:solidFill>
                 <a:latin typeface="Aptos"/>
               </a:rPr>
-              <a:t>treinar e validar model.joblib</a:t>
+              <a:t>treinar e confirmar model.joblib</a:t>
             </a:r>
           </a:p>
         </p:txBody>

</xml_diff>